<commit_message>
Update names and links on readme and slides
</commit_message>
<xml_diff>
--- a/Intro-to-R-master/intro_to_r_slide.pptx
+++ b/Intro-to-R-master/intro_to_r_slide.pptx
@@ -114,6 +114,89 @@
 </p:presentation>
 </file>
 
+<file path=ppt/revisionInfo.xml><?xml version="1.0" encoding="utf-8"?>
+<p1510:revInfo xmlns:a="http://schemas.openxmlformats.org/drawingml/2006/main" xmlns:r="http://schemas.openxmlformats.org/officeDocument/2006/relationships" xmlns:p1510="http://schemas.microsoft.com/office/powerpoint/2015/10/main">
+  <p1510:revLst>
+    <p1510:client id="{1FD20EF8-6FAB-4C49-8131-E00C8D8A8C71}" v="4" dt="2026-01-20T02:44:08.399"/>
+  </p1510:revLst>
+</p1510:revInfo>
+</file>
+
+<file path=ppt/changesInfos/changesInfo1.xml><?xml version="1.0" encoding="utf-8"?>
+<pc:chgInfo xmlns:a="http://schemas.openxmlformats.org/drawingml/2006/main" xmlns:r="http://schemas.openxmlformats.org/officeDocument/2006/relationships" xmlns:ac="http://schemas.microsoft.com/office/drawing/2013/main/command" xmlns:pc="http://schemas.microsoft.com/office/powerpoint/2013/main/command">
+  <pc:docChgLst>
+    <pc:chgData name="David Hirst" userId="5e516591-6f1f-4bff-bec1-ca5c5a42f69d" providerId="ADAL" clId="{F4486C68-68EE-5004-AD35-4539952C1C95}"/>
+    <pc:docChg chg="custSel modSld">
+      <pc:chgData name="David Hirst" userId="5e516591-6f1f-4bff-bec1-ca5c5a42f69d" providerId="ADAL" clId="{F4486C68-68EE-5004-AD35-4539952C1C95}" dt="2026-01-20T02:44:18.993" v="23" actId="1076"/>
+      <pc:docMkLst>
+        <pc:docMk/>
+      </pc:docMkLst>
+      <pc:sldChg chg="modSp">
+        <pc:chgData name="David Hirst" userId="5e516591-6f1f-4bff-bec1-ca5c5a42f69d" providerId="ADAL" clId="{F4486C68-68EE-5004-AD35-4539952C1C95}" dt="2026-01-20T02:42:35.851" v="14"/>
+        <pc:sldMkLst>
+          <pc:docMk/>
+          <pc:sldMk cId="729741413" sldId="256"/>
+        </pc:sldMkLst>
+        <pc:spChg chg="mod">
+          <ac:chgData name="David Hirst" userId="5e516591-6f1f-4bff-bec1-ca5c5a42f69d" providerId="ADAL" clId="{F4486C68-68EE-5004-AD35-4539952C1C95}" dt="2026-01-20T02:42:35.851" v="14"/>
+          <ac:spMkLst>
+            <pc:docMk/>
+            <pc:sldMk cId="729741413" sldId="256"/>
+            <ac:spMk id="3" creationId="{EA782C15-77D4-E93F-4BC9-4D2ABF0AF68F}"/>
+          </ac:spMkLst>
+        </pc:spChg>
+      </pc:sldChg>
+      <pc:sldChg chg="addSp delSp modSp mod">
+        <pc:chgData name="David Hirst" userId="5e516591-6f1f-4bff-bec1-ca5c5a42f69d" providerId="ADAL" clId="{F4486C68-68EE-5004-AD35-4539952C1C95}" dt="2026-01-20T02:44:18.993" v="23" actId="1076"/>
+        <pc:sldMkLst>
+          <pc:docMk/>
+          <pc:sldMk cId="1812427107" sldId="257"/>
+        </pc:sldMkLst>
+        <pc:spChg chg="mod">
+          <ac:chgData name="David Hirst" userId="5e516591-6f1f-4bff-bec1-ca5c5a42f69d" providerId="ADAL" clId="{F4486C68-68EE-5004-AD35-4539952C1C95}" dt="2026-01-20T02:43:05.087" v="15"/>
+          <ac:spMkLst>
+            <pc:docMk/>
+            <pc:sldMk cId="1812427107" sldId="257"/>
+            <ac:spMk id="3" creationId="{B1ADB643-1149-9EB2-C10D-B1BCB691D26B}"/>
+          </ac:spMkLst>
+        </pc:spChg>
+        <pc:picChg chg="add mod">
+          <ac:chgData name="David Hirst" userId="5e516591-6f1f-4bff-bec1-ca5c5a42f69d" providerId="ADAL" clId="{F4486C68-68EE-5004-AD35-4539952C1C95}" dt="2026-01-20T02:44:18.993" v="23" actId="1076"/>
+          <ac:picMkLst>
+            <pc:docMk/>
+            <pc:sldMk cId="1812427107" sldId="257"/>
+            <ac:picMk id="6" creationId="{CC4324AB-1574-A798-12C5-3BF71A7F2C4A}"/>
+          </ac:picMkLst>
+        </pc:picChg>
+        <pc:picChg chg="del">
+          <ac:chgData name="David Hirst" userId="5e516591-6f1f-4bff-bec1-ca5c5a42f69d" providerId="ADAL" clId="{F4486C68-68EE-5004-AD35-4539952C1C95}" dt="2026-01-20T02:43:56.021" v="16" actId="478"/>
+          <ac:picMkLst>
+            <pc:docMk/>
+            <pc:sldMk cId="1812427107" sldId="257"/>
+            <ac:picMk id="9" creationId="{5F65C59C-847B-04B1-5521-4E8D514EE7EE}"/>
+          </ac:picMkLst>
+        </pc:picChg>
+      </pc:sldChg>
+      <pc:sldChg chg="modSp mod">
+        <pc:chgData name="David Hirst" userId="5e516591-6f1f-4bff-bec1-ca5c5a42f69d" providerId="ADAL" clId="{F4486C68-68EE-5004-AD35-4539952C1C95}" dt="2026-01-20T02:42:04.169" v="13"/>
+        <pc:sldMkLst>
+          <pc:docMk/>
+          <pc:sldMk cId="1525127599" sldId="258"/>
+        </pc:sldMkLst>
+        <pc:spChg chg="mod">
+          <ac:chgData name="David Hirst" userId="5e516591-6f1f-4bff-bec1-ca5c5a42f69d" providerId="ADAL" clId="{F4486C68-68EE-5004-AD35-4539952C1C95}" dt="2026-01-20T02:42:04.169" v="13"/>
+          <ac:spMkLst>
+            <pc:docMk/>
+            <pc:sldMk cId="1525127599" sldId="258"/>
+            <ac:spMk id="3" creationId="{40A59052-BEB2-6B59-BC1D-4DB38D00AB29}"/>
+          </ac:spMkLst>
+        </pc:spChg>
+      </pc:sldChg>
+    </pc:docChg>
+  </pc:docChgLst>
+</pc:chgInfo>
+</file>
+
 <file path=ppt/slideLayouts/slideLayout1.xml><?xml version="1.0" encoding="utf-8"?>
 <p:sldLayout xmlns:a="http://schemas.openxmlformats.org/drawingml/2006/main" xmlns:r="http://schemas.openxmlformats.org/officeDocument/2006/relationships" xmlns:p="http://schemas.openxmlformats.org/presentationml/2006/main" type="title" preserve="1">
   <p:cSld name="Title Slide">
@@ -263,7 +346,7 @@
           <a:p>
             <a:fld id="{3B23EC7E-BCD4-FA40-A355-9C4843A3287E}" type="datetimeFigureOut">
               <a:rPr lang="en-US" smtClean="0"/>
-              <a:t>2/5/25</a:t>
+              <a:t>1/20/26</a:t>
             </a:fld>
             <a:endParaRPr lang="en-US"/>
           </a:p>
@@ -463,7 +546,7 @@
           <a:p>
             <a:fld id="{3B23EC7E-BCD4-FA40-A355-9C4843A3287E}" type="datetimeFigureOut">
               <a:rPr lang="en-US" smtClean="0"/>
-              <a:t>2/5/25</a:t>
+              <a:t>1/20/26</a:t>
             </a:fld>
             <a:endParaRPr lang="en-US"/>
           </a:p>
@@ -673,7 +756,7 @@
           <a:p>
             <a:fld id="{3B23EC7E-BCD4-FA40-A355-9C4843A3287E}" type="datetimeFigureOut">
               <a:rPr lang="en-US" smtClean="0"/>
-              <a:t>2/5/25</a:t>
+              <a:t>1/20/26</a:t>
             </a:fld>
             <a:endParaRPr lang="en-US"/>
           </a:p>
@@ -873,7 +956,7 @@
           <a:p>
             <a:fld id="{3B23EC7E-BCD4-FA40-A355-9C4843A3287E}" type="datetimeFigureOut">
               <a:rPr lang="en-US" smtClean="0"/>
-              <a:t>2/5/25</a:t>
+              <a:t>1/20/26</a:t>
             </a:fld>
             <a:endParaRPr lang="en-US"/>
           </a:p>
@@ -1149,7 +1232,7 @@
           <a:p>
             <a:fld id="{3B23EC7E-BCD4-FA40-A355-9C4843A3287E}" type="datetimeFigureOut">
               <a:rPr lang="en-US" smtClean="0"/>
-              <a:t>2/5/25</a:t>
+              <a:t>1/20/26</a:t>
             </a:fld>
             <a:endParaRPr lang="en-US"/>
           </a:p>
@@ -1417,7 +1500,7 @@
           <a:p>
             <a:fld id="{3B23EC7E-BCD4-FA40-A355-9C4843A3287E}" type="datetimeFigureOut">
               <a:rPr lang="en-US" smtClean="0"/>
-              <a:t>2/5/25</a:t>
+              <a:t>1/20/26</a:t>
             </a:fld>
             <a:endParaRPr lang="en-US"/>
           </a:p>
@@ -1832,7 +1915,7 @@
           <a:p>
             <a:fld id="{3B23EC7E-BCD4-FA40-A355-9C4843A3287E}" type="datetimeFigureOut">
               <a:rPr lang="en-US" smtClean="0"/>
-              <a:t>2/5/25</a:t>
+              <a:t>1/20/26</a:t>
             </a:fld>
             <a:endParaRPr lang="en-US"/>
           </a:p>
@@ -1974,7 +2057,7 @@
           <a:p>
             <a:fld id="{3B23EC7E-BCD4-FA40-A355-9C4843A3287E}" type="datetimeFigureOut">
               <a:rPr lang="en-US" smtClean="0"/>
-              <a:t>2/5/25</a:t>
+              <a:t>1/20/26</a:t>
             </a:fld>
             <a:endParaRPr lang="en-US"/>
           </a:p>
@@ -2087,7 +2170,7 @@
           <a:p>
             <a:fld id="{3B23EC7E-BCD4-FA40-A355-9C4843A3287E}" type="datetimeFigureOut">
               <a:rPr lang="en-US" smtClean="0"/>
-              <a:t>2/5/25</a:t>
+              <a:t>1/20/26</a:t>
             </a:fld>
             <a:endParaRPr lang="en-US"/>
           </a:p>
@@ -2400,7 +2483,7 @@
           <a:p>
             <a:fld id="{3B23EC7E-BCD4-FA40-A355-9C4843A3287E}" type="datetimeFigureOut">
               <a:rPr lang="en-US" smtClean="0"/>
-              <a:t>2/5/25</a:t>
+              <a:t>1/20/26</a:t>
             </a:fld>
             <a:endParaRPr lang="en-US"/>
           </a:p>
@@ -2689,7 +2772,7 @@
           <a:p>
             <a:fld id="{3B23EC7E-BCD4-FA40-A355-9C4843A3287E}" type="datetimeFigureOut">
               <a:rPr lang="en-US" smtClean="0"/>
-              <a:t>2/5/25</a:t>
+              <a:t>1/20/26</a:t>
             </a:fld>
             <a:endParaRPr lang="en-US"/>
           </a:p>
@@ -2932,7 +3015,7 @@
           <a:p>
             <a:fld id="{3B23EC7E-BCD4-FA40-A355-9C4843A3287E}" type="datetimeFigureOut">
               <a:rPr lang="en-US" smtClean="0"/>
-              <a:t>2/5/25</a:t>
+              <a:t>1/20/26</a:t>
             </a:fld>
             <a:endParaRPr lang="en-US"/>
           </a:p>
@@ -3468,7 +3551,15 @@
             <a:pPr algn="l"/>
             <a:r>
               <a:rPr lang="en-US" dirty="0"/>
-              <a:t>Saritha Kodikara, Eva Hamrud</a:t>
+              <a:t>David Hirst, </a:t>
+            </a:r>
+            <a:r>
+              <a:rPr lang="en-US" dirty="0" err="1"/>
+              <a:t>Chengyi</a:t>
+            </a:r>
+            <a:r>
+              <a:rPr lang="en-US" dirty="0"/>
+              <a:t> Ma, Yiwen Wang</a:t>
             </a:r>
           </a:p>
         </p:txBody>
@@ -3881,7 +3972,15 @@
             <a:pPr algn="l"/>
             <a:r>
               <a:rPr lang="en-US" dirty="0"/>
-              <a:t>Saritha Kodikara, Eva Hamrud</a:t>
+              <a:t>David Hirst, </a:t>
+            </a:r>
+            <a:r>
+              <a:rPr lang="en-US" dirty="0" err="1"/>
+              <a:t>Chengyi</a:t>
+            </a:r>
+            <a:r>
+              <a:rPr lang="en-US" dirty="0"/>
+              <a:t> Ma, Yiwen Wang</a:t>
             </a:r>
           </a:p>
         </p:txBody>
@@ -4386,7 +4485,15 @@
             <a:pPr algn="l"/>
             <a:r>
               <a:rPr lang="en-US" dirty="0"/>
-              <a:t>Saritha Kodikara, Eva Hamrud</a:t>
+              <a:t>David Hirst, </a:t>
+            </a:r>
+            <a:r>
+              <a:rPr lang="en-US" dirty="0" err="1"/>
+              <a:t>Chengyi</a:t>
+            </a:r>
+            <a:r>
+              <a:rPr lang="en-US" dirty="0"/>
+              <a:t> Ma, Yiwen Wang</a:t>
             </a:r>
           </a:p>
         </p:txBody>
@@ -4520,36 +4627,6 @@
           </a:extLst>
         </p:spPr>
       </p:pic>
-      <p:pic>
-        <p:nvPicPr>
-          <p:cNvPr id="9" name="Picture 8" descr="A qr code with a black background&#10;&#10;AI-generated content may be incorrect.">
-            <a:extLst>
-              <a:ext uri="{FF2B5EF4-FFF2-40B4-BE49-F238E27FC236}">
-                <a16:creationId xmlns:a16="http://schemas.microsoft.com/office/drawing/2014/main" id="{5F65C59C-847B-04B1-5521-4E8D514EE7EE}"/>
-              </a:ext>
-            </a:extLst>
-          </p:cNvPr>
-          <p:cNvPicPr>
-            <a:picLocks noChangeAspect="1"/>
-          </p:cNvPicPr>
-          <p:nvPr/>
-        </p:nvPicPr>
-        <p:blipFill>
-          <a:blip r:embed="rId3"/>
-          <a:stretch>
-            <a:fillRect/>
-          </a:stretch>
-        </p:blipFill>
-        <p:spPr>
-          <a:xfrm>
-            <a:off x="4145382" y="2789984"/>
-            <a:ext cx="3498980" cy="3498980"/>
-          </a:xfrm>
-          <a:prstGeom prst="rect">
-            <a:avLst/>
-          </a:prstGeom>
-        </p:spPr>
-      </p:pic>
       <p:sp>
         <p:nvSpPr>
           <p:cNvPr id="11" name="Rounded Rectangle 10">
@@ -4622,10 +4699,10 @@
           <p:nvPr/>
         </p:nvPicPr>
         <p:blipFill>
-          <a:blip r:embed="rId4">
+          <a:blip r:embed="rId3">
             <a:extLst>
               <a:ext uri="{96DAC541-7B7A-43D3-8B79-37D633B846F1}">
-                <asvg:svgBlip xmlns:asvg="http://schemas.microsoft.com/office/drawing/2016/SVG/main" r:embed="rId5"/>
+                <asvg:svgBlip xmlns:asvg="http://schemas.microsoft.com/office/drawing/2016/SVG/main" r:embed="rId4"/>
               </a:ext>
             </a:extLst>
           </a:blip>
@@ -4701,6 +4778,36 @@
           </a:p>
         </p:txBody>
       </p:sp>
+      <p:pic>
+        <p:nvPicPr>
+          <p:cNvPr id="6" name="Picture 5" descr="A qr code with black squares&#10;&#10;AI-generated content may be incorrect.">
+            <a:extLst>
+              <a:ext uri="{FF2B5EF4-FFF2-40B4-BE49-F238E27FC236}">
+                <a16:creationId xmlns:a16="http://schemas.microsoft.com/office/drawing/2014/main" id="{CC4324AB-1574-A798-12C5-3BF71A7F2C4A}"/>
+              </a:ext>
+            </a:extLst>
+          </p:cNvPr>
+          <p:cNvPicPr>
+            <a:picLocks noChangeAspect="1"/>
+          </p:cNvPicPr>
+          <p:nvPr/>
+        </p:nvPicPr>
+        <p:blipFill>
+          <a:blip r:embed="rId5"/>
+          <a:stretch>
+            <a:fillRect/>
+          </a:stretch>
+        </p:blipFill>
+        <p:spPr>
+          <a:xfrm>
+            <a:off x="3983274" y="2761955"/>
+            <a:ext cx="3529977" cy="3529977"/>
+          </a:xfrm>
+          <a:prstGeom prst="rect">
+            <a:avLst/>
+          </a:prstGeom>
+        </p:spPr>
+      </p:pic>
     </p:spTree>
     <p:extLst>
       <p:ext uri="{BB962C8B-B14F-4D97-AF65-F5344CB8AC3E}">

</xml_diff>